<commit_message>
Tighten Bash lab grading and sample output
</commit_message>
<xml_diff>
--- a/labs/220-bash-scripting-health-checks/assets/Bash Scripting Health Checks SUBMISSION TEMPLATE.pptx
+++ b/labs/220-bash-scripting-health-checks/assets/Bash Scripting Health Checks SUBMISSION TEMPLATE.pptx
@@ -7284,8 +7284,8 @@
               <a:buNone/>
             </a:pPr>
             <a:r>
-              <a:rPr sz="2400"/>
-              <a:t>Screenshot 5 No Reply Returns Exit Code 1.</a:t>
+              <a:rPr sz="2200"/>
+              <a:t>Screenshot 5 Failure Path Returns a Diagnostic Exit Code.</a:t>
             </a:r>
             <a:endParaRPr/>
           </a:p>

</xml_diff>